<commit_message>
feat: add animation support to slides
- Introduced Animation struct and related types for defining animations on slide shapes.
- Implemented methods for adding animations to slides and generating corresponding XML.
- Enhanced slide rendering to include animations in the output.
- Added validation for animation effects and triggers.
- Created tests for animation functionality and ensured compatibility with existing slide features.
- Developed a smoke test script to generate a sample presentation demonstrating animations and transitions.
</commit_message>
<xml_diff>
--- a/smoke_samples/family1_bar_line_area_variants.pptx
+++ b/smoke_samples/family1_bar_line_area_variants.pptx
@@ -748,8 +748,133 @@
 </file>
 
 <file path=ppt/slideLayouts/slideLayout1.xml><?xml version="1.0" encoding="utf-8"?>
-<p:sldLayout xmlns:a="http://schemas.openxmlformats.org/drawingml/2006/main" xmlns:r="http://schemas.openxmlformats.org/officeDocument/2006/relationships" xmlns:p="http://schemas.openxmlformats.org/presentationml/2006/main" type="blank" preserve="1">
+<p:sldLayout xmlns:a="http://schemas.openxmlformats.org/drawingml/2006/main" xmlns:r="http://schemas.openxmlformats.org/officeDocument/2006/relationships" xmlns:p="http://schemas.openxmlformats.org/presentationml/2006/main" preserve="1">
+  <p:cSld name="Title and Content">
+    <p:spTree>
+      <p:nvGrpSpPr>
+        <p:cNvPr id="1" name=""/>
+        <p:cNvGrpSpPr/>
+        <p:nvPr/>
+      </p:nvGrpSpPr>
+      <p:grpSpPr>
+        <a:xfrm>
+          <a:off x="0" y="0"/>
+          <a:ext cx="0" cy="0"/>
+          <a:chOff x="0" y="0"/>
+          <a:chExt cx="0" cy="0"/>
+        </a:xfrm>
+      </p:grpSpPr>
+    </p:spTree>
+  </p:cSld>
+  <p:clrMapOvr>
+    <a:masterClrMapping/>
+  </p:clrMapOvr>
+</p:sldLayout>
+</file>
+
+<file path=ppt/slideLayouts/slideLayout2.xml><?xml version="1.0" encoding="utf-8"?>
+<p:sldLayout xmlns:a="http://schemas.openxmlformats.org/drawingml/2006/main" xmlns:r="http://schemas.openxmlformats.org/officeDocument/2006/relationships" xmlns:p="http://schemas.openxmlformats.org/presentationml/2006/main" preserve="1">
+  <p:cSld name="Title Only">
+    <p:spTree>
+      <p:nvGrpSpPr>
+        <p:cNvPr id="1" name=""/>
+        <p:cNvGrpSpPr/>
+        <p:nvPr/>
+      </p:nvGrpSpPr>
+      <p:grpSpPr>
+        <a:xfrm>
+          <a:off x="0" y="0"/>
+          <a:ext cx="0" cy="0"/>
+          <a:chOff x="0" y="0"/>
+          <a:chExt cx="0" cy="0"/>
+        </a:xfrm>
+      </p:grpSpPr>
+    </p:spTree>
+  </p:cSld>
+  <p:clrMapOvr>
+    <a:masterClrMapping/>
+  </p:clrMapOvr>
+</p:sldLayout>
+</file>
+
+<file path=ppt/slideLayouts/slideLayout3.xml><?xml version="1.0" encoding="utf-8"?>
+<p:sldLayout xmlns:a="http://schemas.openxmlformats.org/drawingml/2006/main" xmlns:r="http://schemas.openxmlformats.org/officeDocument/2006/relationships" xmlns:p="http://schemas.openxmlformats.org/presentationml/2006/main" preserve="1">
   <p:cSld name="Blank">
+    <p:spTree>
+      <p:nvGrpSpPr>
+        <p:cNvPr id="1" name=""/>
+        <p:cNvGrpSpPr/>
+        <p:nvPr/>
+      </p:nvGrpSpPr>
+      <p:grpSpPr>
+        <a:xfrm>
+          <a:off x="0" y="0"/>
+          <a:ext cx="0" cy="0"/>
+          <a:chOff x="0" y="0"/>
+          <a:chExt cx="0" cy="0"/>
+        </a:xfrm>
+      </p:grpSpPr>
+    </p:spTree>
+  </p:cSld>
+  <p:clrMapOvr>
+    <a:masterClrMapping/>
+  </p:clrMapOvr>
+</p:sldLayout>
+</file>
+
+<file path=ppt/slideLayouts/slideLayout4.xml><?xml version="1.0" encoding="utf-8"?>
+<p:sldLayout xmlns:a="http://schemas.openxmlformats.org/drawingml/2006/main" xmlns:r="http://schemas.openxmlformats.org/officeDocument/2006/relationships" xmlns:p="http://schemas.openxmlformats.org/presentationml/2006/main" preserve="1">
+  <p:cSld name="Centered Title">
+    <p:spTree>
+      <p:nvGrpSpPr>
+        <p:cNvPr id="1" name=""/>
+        <p:cNvGrpSpPr/>
+        <p:nvPr/>
+      </p:nvGrpSpPr>
+      <p:grpSpPr>
+        <a:xfrm>
+          <a:off x="0" y="0"/>
+          <a:ext cx="0" cy="0"/>
+          <a:chOff x="0" y="0"/>
+          <a:chExt cx="0" cy="0"/>
+        </a:xfrm>
+      </p:grpSpPr>
+    </p:spTree>
+  </p:cSld>
+  <p:clrMapOvr>
+    <a:masterClrMapping/>
+  </p:clrMapOvr>
+</p:sldLayout>
+</file>
+
+<file path=ppt/slideLayouts/slideLayout5.xml><?xml version="1.0" encoding="utf-8"?>
+<p:sldLayout xmlns:a="http://schemas.openxmlformats.org/drawingml/2006/main" xmlns:r="http://schemas.openxmlformats.org/officeDocument/2006/relationships" xmlns:p="http://schemas.openxmlformats.org/presentationml/2006/main" preserve="1">
+  <p:cSld name="Title and Big Content">
+    <p:spTree>
+      <p:nvGrpSpPr>
+        <p:cNvPr id="1" name=""/>
+        <p:cNvGrpSpPr/>
+        <p:nvPr/>
+      </p:nvGrpSpPr>
+      <p:grpSpPr>
+        <a:xfrm>
+          <a:off x="0" y="0"/>
+          <a:ext cx="0" cy="0"/>
+          <a:chOff x="0" y="0"/>
+          <a:chExt cx="0" cy="0"/>
+        </a:xfrm>
+      </p:grpSpPr>
+    </p:spTree>
+  </p:cSld>
+  <p:clrMapOvr>
+    <a:masterClrMapping/>
+  </p:clrMapOvr>
+</p:sldLayout>
+</file>
+
+<file path=ppt/slideLayouts/slideLayout6.xml><?xml version="1.0" encoding="utf-8"?>
+<p:sldLayout xmlns:a="http://schemas.openxmlformats.org/drawingml/2006/main" xmlns:r="http://schemas.openxmlformats.org/officeDocument/2006/relationships" xmlns:p="http://schemas.openxmlformats.org/presentationml/2006/main" preserve="1">
+  <p:cSld name="Two Column">
     <p:spTree>
       <p:nvGrpSpPr>
         <p:cNvPr id="1" name=""/>
@@ -799,6 +924,11 @@
   <p:clrMap bg1="lt1" tx1="dk1" bg2="lt2" tx2="dk2" accent1="accent1" accent2="accent2" accent3="accent3" accent4="accent4" accent5="accent5" accent6="accent6" hlink="hlink" folHlink="folHlink"/>
   <p:sldLayoutIdLst>
     <p:sldLayoutId id="2147483649" r:id="rId1"/>
+    <p:sldLayoutId id="2147483650" r:id="rId2"/>
+    <p:sldLayoutId id="2147483651" r:id="rId3"/>
+    <p:sldLayoutId id="2147483652" r:id="rId4"/>
+    <p:sldLayoutId id="2147483653" r:id="rId5"/>
+    <p:sldLayoutId id="2147483654" r:id="rId6"/>
   </p:sldLayoutIdLst>
 </p:sldMaster>
 </file>
@@ -1379,9 +1509,70 @@
         <a:solidFill>
           <a:schemeClr val="phClr"/>
         </a:solidFill>
+        <a:gradFill rotWithShape="1">
+          <a:gsLst>
+            <a:gs pos="0">
+              <a:schemeClr val="phClr">
+                <a:tint val="50000"/>
+                <a:satMod val="300000"/>
+              </a:schemeClr>
+            </a:gs>
+            <a:gs pos="35000">
+              <a:schemeClr val="phClr">
+                <a:tint val="37000"/>
+                <a:satMod val="300000"/>
+              </a:schemeClr>
+            </a:gs>
+            <a:gs pos="100000">
+              <a:schemeClr val="phClr">
+                <a:tint val="15000"/>
+                <a:satMod val="350000"/>
+              </a:schemeClr>
+            </a:gs>
+          </a:gsLst>
+          <a:lin ang="16200000" scaled="1"/>
+        </a:gradFill>
+        <a:gradFill rotWithShape="1">
+          <a:gsLst>
+            <a:gs pos="0">
+              <a:schemeClr val="phClr">
+                <a:shade val="51000"/>
+                <a:satMod val="130000"/>
+              </a:schemeClr>
+            </a:gs>
+            <a:gs pos="80000">
+              <a:schemeClr val="phClr">
+                <a:shade val="93000"/>
+                <a:satMod val="130000"/>
+              </a:schemeClr>
+            </a:gs>
+            <a:gs pos="100000">
+              <a:schemeClr val="phClr">
+                <a:shade val="94000"/>
+                <a:satMod val="135000"/>
+              </a:schemeClr>
+            </a:gs>
+          </a:gsLst>
+          <a:lin ang="16200000" scaled="0"/>
+        </a:gradFill>
       </a:fillStyleLst>
       <a:lnStyleLst>
         <a:ln w="9525" cap="flat" cmpd="sng" algn="ctr">
+          <a:solidFill>
+            <a:schemeClr val="phClr">
+              <a:shade val="95000"/>
+              <a:satMod val="105000"/>
+            </a:schemeClr>
+          </a:solidFill>
+          <a:prstDash val="solid"/>
+        </a:ln>
+        <a:ln w="25400" cap="flat" cmpd="sng" algn="ctr">
+          <a:solidFill>
+            <a:schemeClr val="phClr"/>
+          </a:solidFill>
+          <a:prstDash val="solid"/>
+        </a:ln>
+        <a:ln w="38100" cap="flat" cmpd="sng" algn="ctr">
           <a:solidFill>
             <a:schemeClr val="phClr"/>
           </a:solidFill>
@@ -1392,11 +1583,62 @@
         <a:effectStyle>
           <a:effectLst/>
         </a:effectStyle>
+        <a:effectStyle>
+          <a:effectLst/>
+        </a:effectStyle>
+        <a:effectStyle>
+          <a:effectLst/>
+        </a:effectStyle>
       </a:effectStyleLst>
       <a:bgFillStyleLst>
         <a:solidFill>
           <a:schemeClr val="phClr"/>
         </a:solidFill>
+        <a:gradFill rotWithShape="1">
+          <a:gsLst>
+            <a:gs pos="0">
+              <a:schemeClr val="phClr">
+                <a:tint val="40000"/>
+                <a:satMod val="350000"/>
+              </a:schemeClr>
+            </a:gs>
+            <a:gs pos="40000">
+              <a:schemeClr val="phClr">
+                <a:tint val="45000"/>
+                <a:shade val="99000"/>
+                <a:satMod val="350000"/>
+              </a:schemeClr>
+            </a:gs>
+            <a:gs pos="100000">
+              <a:schemeClr val="phClr">
+                <a:shade val="20000"/>
+                <a:satMod val="255000"/>
+              </a:schemeClr>
+            </a:gs>
+          </a:gsLst>
+          <a:path path="circle">
+            <a:fillToRect l="50000" t="-80000" r="50000" b="180000"/>
+          </a:path>
+        </a:gradFill>
+        <a:gradFill rotWithShape="1">
+          <a:gsLst>
+            <a:gs pos="0">
+              <a:schemeClr val="phClr">
+                <a:tint val="80000"/>
+                <a:satMod val="300000"/>
+              </a:schemeClr>
+            </a:gs>
+            <a:gs pos="100000">
+              <a:schemeClr val="phClr">
+                <a:shade val="30000"/>
+                <a:satMod val="200000"/>
+              </a:schemeClr>
+            </a:gs>
+          </a:gsLst>
+          <a:path path="circle">
+            <a:fillToRect l="50000" t="50000" r="50000" b="50000"/>
+          </a:path>
+        </a:gradFill>
       </a:bgFillStyleLst>
     </a:fmtScheme>
   </a:themeElements>

</xml_diff>